<commit_message>
refactorizare modul 1 si 2
Modul 2: extra-02 devin seminar-02a (cheat-sheet pandas) si seminar-02b
(exemple de grafice + exercitii pe lab-set4 cu valori de control, interpretare
si Jurnal AI); seminarul-cadru integrat in 2b. Corecturi in temele 02a/02b
(index lab-set5, solutie scursa, pie pe medii, praguri Ex.6, Ex.2 pe produs),
curs vizualizare (tabel 0.3075, figuri, imagini locale, sectiune distributii/
boxplot, fara referinte la client), deck EDA (SEED1, referinta Tukey, slide-urile
de preprocesare mutate). Slide-urile mutate devin extra-03..06 (standardizare,
codificare, balansare, pipeline) si sunt adaugate ca text in notebook-urile de
curs 3, 4, 5b, 6.

Modul 1: extra-01 anaconda scos, seminar-01 actualizat, primer Claude Code.

Co-Authored-By: Claude Sonnet 5.5 <noreply@anthropic.com>
</commit_message>
<xml_diff>
--- a/cursuri/02-explorare-vizualizare/curs-02-vizualizarea-datelor.pptx
+++ b/cursuri/02-explorare-vizualizare/curs-02-vizualizarea-datelor.pptx
@@ -12132,11 +12132,11 @@
             </a:pPr>
             <a:r>
               <a:rPr lang="en" dirty="0"/>
-              <a:t>ADS1 - Curs </a:t>
+              <a:t>SEED1 - Curs </a:t>
             </a:r>
             <a:r>
               <a:rPr lang="ro-RO" dirty="0"/>
-              <a:t>3</a:t>
+              <a:t>2</a:t>
             </a:r>
             <a:br>
               <a:rPr lang="en" dirty="0"/>
@@ -16418,7 +16418,7 @@
                       </a:pPr>
                       <a:r>
                         <a:rPr lang="en" sz="1000" dirty="0"/>
-                        <a:t>Media curenta - 0.005 =0.3120 sau 31.20</a:t>
+                        <a:t>Media curenta - 0.005 =0.3075 sau 30.75%</a:t>
                       </a:r>
                       <a:endParaRPr sz="1000" dirty="0"/>
                     </a:p>

</xml_diff>